<commit_message>
slides: wrap explanatory text inside auto-sizing boxes + define "isoform"
The three explanatory callouts (pipeline legend, single-core failure modes,
runaway-read defenses) were fixed-rectangle + free text that overflowed the
box edges. Replace each with a matplotlib bbox that auto-sizes to the text,
and pre-wrap the strings with textwrap.fill so every line stays inside the
figure (pipeline 112, single-core 90, runaway 92 chars). Add a slide-2
footnote defining "isoform" (a distinct splice variant / intron chain) and
clarifying that step (1) collapses isoforms sharing a junction into ONE gene
LOCUS, so a family is a set of loci (genes/copies), not of isoforms.

Co-Authored-By: Claude Opus 4.8 (1M context) <noreply@anthropic.com>
Claude-Session: https://claude.ai/code/session_018funJhdseQMj6htigjdqhk
</commit_message>
<xml_diff>
--- a/bench/slides/family_slides.pptx
+++ b/bench/slides/family_slides.pptx
@@ -3252,14 +3252,48 @@
         </p:blipFill>
         <p:spPr>
           <a:xfrm>
-            <a:off x="700887" y="1371600"/>
-            <a:ext cx="10789920" cy="2616493"/>
+            <a:off x="725904" y="1234440"/>
+            <a:ext cx="10739886" cy="4572000"/>
           </a:xfrm>
           <a:prstGeom prst="rect">
             <a:avLst/>
           </a:prstGeom>
         </p:spPr>
       </p:pic>
+      <p:sp>
+        <p:nvSpPr>
+          <p:cNvPr id="4" name="TextBox 3"/>
+          <p:cNvSpPr txBox="1"/>
+          <p:nvPr/>
+        </p:nvSpPr>
+        <p:spPr>
+          <a:xfrm>
+            <a:off x="502920" y="6172200"/>
+            <a:ext cx="11201400" cy="640080"/>
+          </a:xfrm>
+          <a:prstGeom prst="rect">
+            <a:avLst/>
+          </a:prstGeom>
+          <a:noFill/>
+        </p:spPr>
+        <p:txBody>
+          <a:bodyPr wrap="square">
+            <a:spAutoFit/>
+          </a:bodyPr>
+          <a:lstStyle/>
+          <a:p>
+            <a:pPr algn="l"/>
+            <a:r>
+              <a:rPr sz="1300" b="0" i="1">
+                <a:solidFill>
+                  <a:srgbClr val="5A5A5A"/>
+                </a:solidFill>
+              </a:rPr>
+              <a:t>isoform = a distinct splice variant of a gene — a particular intron chain (which exons are joined). One gene can express several isoforms; step ① collapses isoforms that share a junction into ONE gene LOCUS, so a family is a set of loci (genes/copies), not of isoforms.</a:t>
+            </a:r>
+          </a:p>
+        </p:txBody>
+      </p:sp>
     </p:spTree>
   </p:cSld>
   <p:clrMapOvr>
@@ -3328,8 +3362,8 @@
         </p:blipFill>
         <p:spPr>
           <a:xfrm>
-            <a:off x="700887" y="1280160"/>
-            <a:ext cx="10789920" cy="4445311"/>
+            <a:off x="1059909" y="1280160"/>
+            <a:ext cx="10071875" cy="5120640"/>
           </a:xfrm>
           <a:prstGeom prst="rect">
             <a:avLst/>
@@ -4391,7 +4425,7 @@
         <p:spPr>
           <a:xfrm>
             <a:off x="700887" y="1234440"/>
-            <a:ext cx="10789920" cy="4185745"/>
+            <a:ext cx="10789920" cy="4925833"/>
           </a:xfrm>
           <a:prstGeom prst="rect">
             <a:avLst/>

</xml_diff>